<commit_message>
Presences v1.1: suppression definitive de la declaration et du marquage automatique des absents (journee vide tant que personne n'a scanne), QR_PERIODE revenu a 30s en production, session employee revalidee a chaque requete (compte sans fiche = ni QR ni carte Ma presence), textes de l'heure limite rendus dynamiques, base et sirh.sql nettoyes (1 employe, 2 comptes, 0 presence), cahier des charges v1.1 et presentation regeneres
</commit_message>
<xml_diff>
--- a/docs/Presentation_GLOBIT_SIRH.pptx
+++ b/docs/Presentation_GLOBIT_SIRH.pptx
@@ -3534,7 +3534,7 @@
                 </a:solidFill>
                 <a:latin typeface="Segoe UI"/>
               </a:rPr>
-              <a:t>Déclaration de présence</a:t>
+              <a:t>Pointage QR sécurisé</a:t>
             </a:r>
           </a:p>
         </p:txBody>
@@ -4327,7 +4327,7 @@
                 </a:solidFill>
                 <a:latin typeface="Segoe UI"/>
               </a:rPr>
-              <a:t>Déclaration d’arrivée/départ auto-responsable avant 10h00, états automatiques.</a:t>
+              <a:t>QR dynamique scanné à la réception : 1er scan = arrivée, 2e scan = départ, code renouvelé toutes les 30 s.</a:t>
             </a:r>
           </a:p>
         </p:txBody>
@@ -6384,7 +6384,7 @@
                 </a:solidFill>
                 <a:latin typeface="Segoe UI"/>
               </a:rPr>
-              <a:t>Appel au mode hors-ligne cache</a:t>
+              <a:t>QR signé HMAC, jamais mis en cache</a:t>
             </a:r>
           </a:p>
         </p:txBody>
@@ -6731,7 +6731,7 @@
                 </a:solidFill>
                 <a:latin typeface="Segoe UI"/>
               </a:rPr>
-              <a:t>Déclaration de présence</a:t>
+              <a:t>Pointage par QR code dynamique</a:t>
             </a:r>
           </a:p>
         </p:txBody>
@@ -6860,7 +6860,7 @@
                 </a:solidFill>
                 <a:latin typeface="Segoe UI"/>
               </a:rPr>
-              <a:t>Marquer votre arrivée avant</a:t>
+              <a:t>Le code change toutes les</a:t>
             </a:r>
           </a:p>
         </p:txBody>
@@ -6895,7 +6895,7 @@
                 </a:solidFill>
                 <a:latin typeface="Segoe UI Black"/>
               </a:rPr>
-              <a:t>10h00</a:t>
+              <a:t>30 secondes</a:t>
             </a:r>
           </a:p>
           <a:p>
@@ -6907,7 +6907,7 @@
                 </a:solidFill>
                 <a:latin typeface="Segoe UI"/>
               </a:rPr>
-              <a:t>Compte à rebours réseau multi-devices</a:t>
+              <a:t>Secret signé, aucune photo réutilisable</a:t>
             </a:r>
           </a:p>
         </p:txBody>
@@ -6965,7 +6965,7 @@
                   <a:srgbClr val="FFFFFF"/>
                 </a:solidFill>
               </a:rPr>
-              <a:t>Avant 08h00</a:t>
+              <a:t>1er scan</a:t>
             </a:r>
           </a:p>
         </p:txBody>
@@ -7023,7 +7023,7 @@
                   <a:srgbClr val="22C55E"/>
                 </a:solidFill>
               </a:rPr>
-              <a:t>Présent</a:t>
+              <a:t>Arrivée</a:t>
             </a:r>
           </a:p>
         </p:txBody>
@@ -7081,7 +7081,7 @@
                   <a:srgbClr val="FFFFFF"/>
                 </a:solidFill>
               </a:rPr>
-              <a:t>08h00 → 10h00</a:t>
+              <a:t>2e scan</a:t>
             </a:r>
           </a:p>
         </p:txBody>
@@ -7139,7 +7139,7 @@
                   <a:srgbClr val="F59E0B"/>
                 </a:solidFill>
               </a:rPr>
-              <a:t>Retard</a:t>
+              <a:t>Départ</a:t>
             </a:r>
           </a:p>
         </p:txBody>
@@ -7197,7 +7197,7 @@
                   <a:srgbClr val="FFFFFF"/>
                 </a:solidFill>
               </a:rPr>
-              <a:t>Après 10h00</a:t>
+              <a:t>3e scan</a:t>
             </a:r>
           </a:p>
         </p:txBody>
@@ -7255,7 +7255,7 @@
                   <a:srgbClr val="F87171"/>
                 </a:solidFill>
               </a:rPr>
-              <a:t>Absent (auto)</a:t>
+              <a:t>Refusé</a:t>
             </a:r>
           </a:p>
         </p:txBody>
@@ -7306,7 +7306,7 @@
                 </a:solidFill>
                 <a:latin typeface="Segoe UI"/>
               </a:rPr>
-              <a:t>L’employé déclare son arrivée dans la journée via le web ou le mobile ; le statut est calculé automatiquement selon l’heure GLOBIT (fuseau Afrique/Kinshasa).</a:t>
+              <a:t>L’employé affiche sur son téléphone un QR signé, renouvelé toutes les 30 secondes ; la réception le scanne et l’heure GLOBIT (fuseau Afrique/Kinshasa) détermine le statut.</a:t>
             </a:r>
           </a:p>
         </p:txBody>
@@ -7385,7 +7385,7 @@
                 </a:solidFill>
                 <a:latin typeface="Segoe UI"/>
               </a:rPr>
-              <a:t>Bouton Départ</a:t>
+              <a:t>QR personnel</a:t>
             </a:r>
           </a:p>
           <a:p>
@@ -7401,7 +7401,7 @@
                 </a:solidFill>
                 <a:latin typeface="Segoe UI"/>
               </a:rPr>
-              <a:t>Complète la journée une fois l’arrivée enregistrée.</a:t>
+              <a:t>Code unique par employé, calculé par le serveur à la demande du téléphone.</a:t>
             </a:r>
           </a:p>
         </p:txBody>
@@ -7480,7 +7480,7 @@
                 </a:solidFill>
                 <a:latin typeface="Segoe UI"/>
               </a:rPr>
-              <a:t>Justification</a:t>
+              <a:t>Deuxième scan</a:t>
             </a:r>
           </a:p>
           <a:p>
@@ -7496,7 +7496,7 @@
                 </a:solidFill>
                 <a:latin typeface="Segoe UI"/>
               </a:rPr>
-              <a:t>L’absent contacte le RH via la messagerie interne.</a:t>
+              <a:t>Le 2e scan de la journée enregistre le départ ; un 3e scan est refusé.</a:t>
             </a:r>
           </a:p>
         </p:txBody>
@@ -7575,7 +7575,7 @@
                 </a:solidFill>
                 <a:latin typeface="Segoe UI"/>
               </a:rPr>
-              <a:t>Régularisation</a:t>
+              <a:t>Sécurité du code</a:t>
             </a:r>
           </a:p>
           <a:p>
@@ -7591,7 +7591,7 @@
                 </a:solidFill>
                 <a:latin typeface="Segoe UI"/>
               </a:rPr>
-              <a:t>Le RH ou la direction marque « justifié » en un clic.</a:t>
+              <a:t>Secret HMAC de 256 bits, rotation de 30 s : photo, capture ou modification sont rejetées.</a:t>
             </a:r>
           </a:p>
         </p:txBody>
@@ -8642,7 +8642,7 @@
                 </a:solidFill>
                 <a:latin typeface="Segoe UI"/>
               </a:rPr>
-              <a:t>Boutons Déclarer / Départ</a:t>
+              <a:t>QR personnel rotatif (30 s)</a:t>
             </a:r>
           </a:p>
         </p:txBody>
@@ -8867,7 +8867,7 @@
                 </a:solidFill>
                 <a:latin typeface="Segoe UI"/>
               </a:rPr>
-              <a:t>L’affichage ne dépend ni du fuseau du navigateur ni de l’horloge du poste : le serveur injecte le temps GLOBIT et la limite de 10h00.</a:t>
+              <a:t>Le serveur injecte le temps GLOBIT (limite de 10h00) et signe un jeton QR valable 30 s : ni le fuseau du navigateur ni l’horloge du poste ne faussent le pointage.</a:t>
             </a:r>
           </a:p>
           <a:p>
@@ -12079,7 +12079,7 @@
                 </a:solidFill>
                 <a:latin typeface="Segoe UI"/>
               </a:rPr>
-              <a:t>Mots de passe hachés, sessions sécurisées, protection CSRF, échappement de toutes les sorties.</a:t>
+              <a:t>Mots de passe hachés, sessions sécurisées, CSRF, échappement HTML ; secret QR de 256 bits par employé, jamais stocké ni affiché en clair.</a:t>
             </a:r>
           </a:p>
         </p:txBody>

</xml_diff>